<commit_message>
Add investor package gifts to EN and ZH decks
</commit_message>
<xml_diff>
--- a/investor-decks/Reborn-Wave-Normal-Investor-Guide-EN.pptx
+++ b/investor-decks/Reborn-Wave-Normal-Investor-Guide-EN.pptx
@@ -5941,7 +5941,7 @@
                 </a:solidFill>
                 <a:latin typeface="Aptos"/>
               </a:rPr>
-              <a:t>Every $500 equals 1 allocation unit. Investors choose which business receives their units.</a:t>
+              <a:t>Each package gives club spending credit, project shares, referral bonus, and selected travel/entertainment gifts.</a:t>
             </a:r>
           </a:p>
         </p:txBody>
@@ -5954,8 +5954,8 @@
         </p:nvSpPr>
         <p:spPr>
           <a:xfrm>
-            <a:off x="914400" y="1600200"/>
-            <a:ext cx="2011680" cy="457200"/>
+            <a:off x="749808" y="1600200"/>
+            <a:ext cx="1234440" cy="457200"/>
           </a:xfrm>
           <a:prstGeom prst="rect">
             <a:avLst/>
@@ -5999,8 +5999,8 @@
         </p:nvSpPr>
         <p:spPr>
           <a:xfrm>
-            <a:off x="960120" y="1719072"/>
-            <a:ext cx="1920240" cy="146304"/>
+            <a:off x="795528" y="1719072"/>
+            <a:ext cx="1143000" cy="146304"/>
           </a:xfrm>
           <a:prstGeom prst="rect">
             <a:avLst/>
@@ -6021,7 +6021,7 @@
                 </a:solidFill>
                 <a:latin typeface="Aptos"/>
               </a:rPr>
-              <a:t>Package</a:t>
+              <a:t>Amount</a:t>
             </a:r>
           </a:p>
         </p:txBody>
@@ -6034,8 +6034,8 @@
         </p:nvSpPr>
         <p:spPr>
           <a:xfrm>
-            <a:off x="2926080" y="1600200"/>
-            <a:ext cx="1280160" cy="457200"/>
+            <a:off x="1984248" y="1600200"/>
+            <a:ext cx="1828800" cy="457200"/>
           </a:xfrm>
           <a:prstGeom prst="rect">
             <a:avLst/>
@@ -6079,8 +6079,8 @@
         </p:nvSpPr>
         <p:spPr>
           <a:xfrm>
-            <a:off x="2971800" y="1719072"/>
-            <a:ext cx="1188719" cy="146304"/>
+            <a:off x="2029967" y="1719072"/>
+            <a:ext cx="1737360" cy="146304"/>
           </a:xfrm>
           <a:prstGeom prst="rect">
             <a:avLst/>
@@ -6101,7 +6101,7 @@
                 </a:solidFill>
                 <a:latin typeface="Aptos"/>
               </a:rPr>
-              <a:t>Amount</a:t>
+              <a:t>Spending credit</a:t>
             </a:r>
           </a:p>
         </p:txBody>
@@ -6114,8 +6114,8 @@
         </p:nvSpPr>
         <p:spPr>
           <a:xfrm>
-            <a:off x="4206240" y="1600200"/>
-            <a:ext cx="1097280" cy="457200"/>
+            <a:off x="3813048" y="1600200"/>
+            <a:ext cx="1234440" cy="457200"/>
           </a:xfrm>
           <a:prstGeom prst="rect">
             <a:avLst/>
@@ -6159,8 +6159,8 @@
         </p:nvSpPr>
         <p:spPr>
           <a:xfrm>
-            <a:off x="4251959" y="1719072"/>
-            <a:ext cx="1005839" cy="146304"/>
+            <a:off x="3858768" y="1719072"/>
+            <a:ext cx="1143000" cy="146304"/>
           </a:xfrm>
           <a:prstGeom prst="rect">
             <a:avLst/>
@@ -6181,7 +6181,7 @@
                 </a:solidFill>
                 <a:latin typeface="Aptos"/>
               </a:rPr>
-              <a:t>Units</a:t>
+              <a:t>Shares</a:t>
             </a:r>
           </a:p>
         </p:txBody>
@@ -6194,8 +6194,8 @@
         </p:nvSpPr>
         <p:spPr>
           <a:xfrm>
-            <a:off x="5303520" y="1600200"/>
-            <a:ext cx="5029200" cy="457200"/>
+            <a:off x="5047488" y="1600200"/>
+            <a:ext cx="1508760" cy="457200"/>
           </a:xfrm>
           <a:prstGeom prst="rect">
             <a:avLst/>
@@ -6239,8 +6239,8 @@
         </p:nvSpPr>
         <p:spPr>
           <a:xfrm>
-            <a:off x="5349240" y="1719072"/>
-            <a:ext cx="4937760" cy="146304"/>
+            <a:off x="5093207" y="1719072"/>
+            <a:ext cx="1417319" cy="146304"/>
           </a:xfrm>
           <a:prstGeom prst="rect">
             <a:avLst/>
@@ -6261,7 +6261,7 @@
                 </a:solidFill>
                 <a:latin typeface="Aptos"/>
               </a:rPr>
-              <a:t>Use case</a:t>
+              <a:t>Referral</a:t>
             </a:r>
           </a:p>
         </p:txBody>
@@ -6274,8 +6274,88 @@
         </p:nvSpPr>
         <p:spPr>
           <a:xfrm>
-            <a:off x="914400" y="2103120"/>
-            <a:ext cx="2011680" cy="530352"/>
+            <a:off x="6556248" y="1600200"/>
+            <a:ext cx="3794760" cy="457200"/>
+          </a:xfrm>
+          <a:prstGeom prst="rect">
+            <a:avLst/>
+          </a:prstGeom>
+          <a:solidFill>
+            <a:srgbClr val="083D44"/>
+          </a:solidFill>
+          <a:ln>
+            <a:solidFill>
+              <a:srgbClr val="22D3EE"/>
+            </a:solidFill>
+          </a:ln>
+        </p:spPr>
+        <p:style>
+          <a:lnRef idx="1">
+            <a:schemeClr val="accent1"/>
+          </a:lnRef>
+          <a:fillRef idx="3">
+            <a:schemeClr val="accent1"/>
+          </a:fillRef>
+          <a:effectRef idx="2">
+            <a:schemeClr val="accent1"/>
+          </a:effectRef>
+          <a:fontRef idx="minor">
+            <a:schemeClr val="lt1"/>
+          </a:fontRef>
+        </p:style>
+        <p:txBody>
+          <a:bodyPr rtlCol="0" anchor="ctr"/>
+          <a:lstStyle/>
+          <a:p>
+            <a:pPr algn="ctr"/>
+          </a:p>
+        </p:txBody>
+      </p:sp>
+      <p:sp>
+        <p:nvSpPr>
+          <p:cNvPr id="18" name="TextBox 17"/>
+          <p:cNvSpPr txBox="1"/>
+          <p:nvPr/>
+        </p:nvSpPr>
+        <p:spPr>
+          <a:xfrm>
+            <a:off x="6601968" y="1719072"/>
+            <a:ext cx="3703320" cy="146304"/>
+          </a:xfrm>
+          <a:prstGeom prst="rect">
+            <a:avLst/>
+          </a:prstGeom>
+          <a:noFill/>
+        </p:spPr>
+        <p:txBody>
+          <a:bodyPr wrap="square">
+            <a:spAutoFit/>
+          </a:bodyPr>
+          <a:lstStyle/>
+          <a:p>
+            <a:pPr algn="ctr"/>
+            <a:r>
+              <a:rPr sz="800" b="1">
+                <a:solidFill>
+                  <a:srgbClr val="FFFFFF"/>
+                </a:solidFill>
+                <a:latin typeface="Aptos"/>
+              </a:rPr>
+              <a:t>Extra gift</a:t>
+            </a:r>
+          </a:p>
+        </p:txBody>
+      </p:sp>
+      <p:sp>
+        <p:nvSpPr>
+          <p:cNvPr id="19" name="Rectangle 18"/>
+          <p:cNvSpPr/>
+          <p:nvPr/>
+        </p:nvSpPr>
+        <p:spPr>
+          <a:xfrm>
+            <a:off x="749808" y="2103120"/>
+            <a:ext cx="1234440" cy="530352"/>
           </a:xfrm>
           <a:prstGeom prst="rect">
             <a:avLst/>
@@ -6313,14 +6393,14 @@
       </p:sp>
       <p:sp>
         <p:nvSpPr>
-          <p:cNvPr id="18" name="TextBox 17"/>
-          <p:cNvSpPr txBox="1"/>
-          <p:nvPr/>
-        </p:nvSpPr>
-        <p:spPr>
-          <a:xfrm>
-            <a:off x="969264" y="2240279"/>
-            <a:ext cx="1901952" cy="146304"/>
+          <p:cNvPr id="20" name="TextBox 19"/>
+          <p:cNvSpPr txBox="1"/>
+          <p:nvPr/>
+        </p:nvSpPr>
+        <p:spPr>
+          <a:xfrm>
+            <a:off x="804671" y="2240279"/>
+            <a:ext cx="1124712" cy="146304"/>
           </a:xfrm>
           <a:prstGeom prst="rect">
             <a:avLst/>
@@ -6341,21 +6421,21 @@
                 </a:solidFill>
                 <a:latin typeface="Aptos"/>
               </a:rPr>
-              <a:t>Starter Unit</a:t>
-            </a:r>
-          </a:p>
-        </p:txBody>
-      </p:sp>
-      <p:sp>
-        <p:nvSpPr>
-          <p:cNvPr id="19" name="Rectangle 18"/>
+              <a:t>$500</a:t>
+            </a:r>
+          </a:p>
+        </p:txBody>
+      </p:sp>
+      <p:sp>
+        <p:nvSpPr>
+          <p:cNvPr id="21" name="Rectangle 20"/>
           <p:cNvSpPr/>
           <p:nvPr/>
         </p:nvSpPr>
         <p:spPr>
           <a:xfrm>
-            <a:off x="2926080" y="2103120"/>
-            <a:ext cx="1280160" cy="530352"/>
+            <a:off x="1984248" y="2103120"/>
+            <a:ext cx="1828800" cy="530352"/>
           </a:xfrm>
           <a:prstGeom prst="rect">
             <a:avLst/>
@@ -6393,14 +6473,14 @@
       </p:sp>
       <p:sp>
         <p:nvSpPr>
-          <p:cNvPr id="20" name="TextBox 19"/>
-          <p:cNvSpPr txBox="1"/>
-          <p:nvPr/>
-        </p:nvSpPr>
-        <p:spPr>
-          <a:xfrm>
-            <a:off x="2980944" y="2240279"/>
-            <a:ext cx="1170431" cy="146304"/>
+          <p:cNvPr id="22" name="TextBox 21"/>
+          <p:cNvSpPr txBox="1"/>
+          <p:nvPr/>
+        </p:nvSpPr>
+        <p:spPr>
+          <a:xfrm>
+            <a:off x="2039112" y="2240279"/>
+            <a:ext cx="1719072" cy="146304"/>
           </a:xfrm>
           <a:prstGeom prst="rect">
             <a:avLst/>
@@ -6421,21 +6501,21 @@
                 </a:solidFill>
                 <a:latin typeface="Aptos"/>
               </a:rPr>
-              <a:t>$500</a:t>
-            </a:r>
-          </a:p>
-        </p:txBody>
-      </p:sp>
-      <p:sp>
-        <p:nvSpPr>
-          <p:cNvPr id="21" name="Rectangle 20"/>
+              <a:t>$500 credit</a:t>
+            </a:r>
+          </a:p>
+        </p:txBody>
+      </p:sp>
+      <p:sp>
+        <p:nvSpPr>
+          <p:cNvPr id="23" name="Rectangle 22"/>
           <p:cNvSpPr/>
           <p:nvPr/>
         </p:nvSpPr>
         <p:spPr>
           <a:xfrm>
-            <a:off x="4206240" y="2103120"/>
-            <a:ext cx="1097280" cy="530352"/>
+            <a:off x="3813048" y="2103120"/>
+            <a:ext cx="1234440" cy="530352"/>
           </a:xfrm>
           <a:prstGeom prst="rect">
             <a:avLst/>
@@ -6473,14 +6553,14 @@
       </p:sp>
       <p:sp>
         <p:nvSpPr>
-          <p:cNvPr id="22" name="TextBox 21"/>
-          <p:cNvSpPr txBox="1"/>
-          <p:nvPr/>
-        </p:nvSpPr>
-        <p:spPr>
-          <a:xfrm>
-            <a:off x="4261103" y="2240279"/>
-            <a:ext cx="987552" cy="146304"/>
+          <p:cNvPr id="24" name="TextBox 23"/>
+          <p:cNvSpPr txBox="1"/>
+          <p:nvPr/>
+        </p:nvSpPr>
+        <p:spPr>
+          <a:xfrm>
+            <a:off x="3867911" y="2240279"/>
+            <a:ext cx="1124712" cy="146304"/>
           </a:xfrm>
           <a:prstGeom prst="rect">
             <a:avLst/>
@@ -6501,21 +6581,21 @@
                 </a:solidFill>
                 <a:latin typeface="Aptos"/>
               </a:rPr>
-              <a:t>1 unit</a:t>
-            </a:r>
-          </a:p>
-        </p:txBody>
-      </p:sp>
-      <p:sp>
-        <p:nvSpPr>
-          <p:cNvPr id="23" name="Rectangle 22"/>
+              <a:t>1 share</a:t>
+            </a:r>
+          </a:p>
+        </p:txBody>
+      </p:sp>
+      <p:sp>
+        <p:nvSpPr>
+          <p:cNvPr id="25" name="Rectangle 24"/>
           <p:cNvSpPr/>
           <p:nvPr/>
         </p:nvSpPr>
         <p:spPr>
           <a:xfrm>
-            <a:off x="5303520" y="2103120"/>
-            <a:ext cx="5029200" cy="530352"/>
+            <a:off x="5047488" y="2103120"/>
+            <a:ext cx="1508760" cy="530352"/>
           </a:xfrm>
           <a:prstGeom prst="rect">
             <a:avLst/>
@@ -6553,14 +6633,14 @@
       </p:sp>
       <p:sp>
         <p:nvSpPr>
-          <p:cNvPr id="24" name="TextBox 23"/>
-          <p:cNvSpPr txBox="1"/>
-          <p:nvPr/>
-        </p:nvSpPr>
-        <p:spPr>
-          <a:xfrm>
-            <a:off x="5358383" y="2240279"/>
-            <a:ext cx="4919472" cy="146304"/>
+          <p:cNvPr id="26" name="TextBox 25"/>
+          <p:cNvSpPr txBox="1"/>
+          <p:nvPr/>
+        </p:nvSpPr>
+        <p:spPr>
+          <a:xfrm>
+            <a:off x="5102351" y="2240279"/>
+            <a:ext cx="1399031" cy="146304"/>
           </a:xfrm>
           <a:prstGeom prst="rect">
             <a:avLst/>
@@ -6580,21 +6660,100 @@
                 </a:solidFill>
                 <a:latin typeface="Aptos"/>
               </a:rPr>
-              <a:t>Good first entry</a:t>
-            </a:r>
-          </a:p>
-        </p:txBody>
-      </p:sp>
-      <p:sp>
-        <p:nvSpPr>
-          <p:cNvPr id="25" name="Rectangle 24"/>
+              <a:t>10% referral</a:t>
+            </a:r>
+          </a:p>
+        </p:txBody>
+      </p:sp>
+      <p:sp>
+        <p:nvSpPr>
+          <p:cNvPr id="27" name="Rectangle 26"/>
           <p:cNvSpPr/>
           <p:nvPr/>
         </p:nvSpPr>
         <p:spPr>
           <a:xfrm>
-            <a:off x="914400" y="2670048"/>
-            <a:ext cx="2011680" cy="530352"/>
+            <a:off x="6556248" y="2103120"/>
+            <a:ext cx="3794760" cy="530352"/>
+          </a:xfrm>
+          <a:prstGeom prst="rect">
+            <a:avLst/>
+          </a:prstGeom>
+          <a:solidFill>
+            <a:srgbClr val="07272D"/>
+          </a:solidFill>
+          <a:ln>
+            <a:solidFill>
+              <a:srgbClr val="1F525A"/>
+            </a:solidFill>
+          </a:ln>
+        </p:spPr>
+        <p:style>
+          <a:lnRef idx="1">
+            <a:schemeClr val="accent1"/>
+          </a:lnRef>
+          <a:fillRef idx="3">
+            <a:schemeClr val="accent1"/>
+          </a:fillRef>
+          <a:effectRef idx="2">
+            <a:schemeClr val="accent1"/>
+          </a:effectRef>
+          <a:fontRef idx="minor">
+            <a:schemeClr val="lt1"/>
+          </a:fontRef>
+        </p:style>
+        <p:txBody>
+          <a:bodyPr rtlCol="0" anchor="ctr"/>
+          <a:lstStyle/>
+          <a:p>
+            <a:pPr algn="ctr"/>
+          </a:p>
+        </p:txBody>
+      </p:sp>
+      <p:sp>
+        <p:nvSpPr>
+          <p:cNvPr id="28" name="TextBox 27"/>
+          <p:cNvSpPr txBox="1"/>
+          <p:nvPr/>
+        </p:nvSpPr>
+        <p:spPr>
+          <a:xfrm>
+            <a:off x="6611112" y="2240279"/>
+            <a:ext cx="3685032" cy="146304"/>
+          </a:xfrm>
+          <a:prstGeom prst="rect">
+            <a:avLst/>
+          </a:prstGeom>
+          <a:noFill/>
+        </p:spPr>
+        <p:txBody>
+          <a:bodyPr wrap="square">
+            <a:spAutoFit/>
+          </a:bodyPr>
+          <a:lstStyle/>
+          <a:p>
+            <a:r>
+              <a:rPr sz="800" b="0">
+                <a:solidFill>
+                  <a:srgbClr val="B9CACF"/>
+                </a:solidFill>
+                <a:latin typeface="Aptos"/>
+              </a:rPr>
+              <a:t>-</a:t>
+            </a:r>
+          </a:p>
+        </p:txBody>
+      </p:sp>
+      <p:sp>
+        <p:nvSpPr>
+          <p:cNvPr id="29" name="Rectangle 28"/>
+          <p:cNvSpPr/>
+          <p:nvPr/>
+        </p:nvSpPr>
+        <p:spPr>
+          <a:xfrm>
+            <a:off x="749808" y="2670048"/>
+            <a:ext cx="1234440" cy="530352"/>
           </a:xfrm>
           <a:prstGeom prst="rect">
             <a:avLst/>
@@ -6632,14 +6791,14 @@
       </p:sp>
       <p:sp>
         <p:nvSpPr>
-          <p:cNvPr id="26" name="TextBox 25"/>
-          <p:cNvSpPr txBox="1"/>
-          <p:nvPr/>
-        </p:nvSpPr>
-        <p:spPr>
-          <a:xfrm>
-            <a:off x="969264" y="2807208"/>
-            <a:ext cx="1901952" cy="146304"/>
+          <p:cNvPr id="30" name="TextBox 29"/>
+          <p:cNvSpPr txBox="1"/>
+          <p:nvPr/>
+        </p:nvSpPr>
+        <p:spPr>
+          <a:xfrm>
+            <a:off x="804671" y="2807208"/>
+            <a:ext cx="1124712" cy="146304"/>
           </a:xfrm>
           <a:prstGeom prst="rect">
             <a:avLst/>
@@ -6660,21 +6819,21 @@
                 </a:solidFill>
                 <a:latin typeface="Aptos"/>
               </a:rPr>
-              <a:t>Builder Pack</a:t>
-            </a:r>
-          </a:p>
-        </p:txBody>
-      </p:sp>
-      <p:sp>
-        <p:nvSpPr>
-          <p:cNvPr id="27" name="Rectangle 26"/>
+              <a:t>$1,000</a:t>
+            </a:r>
+          </a:p>
+        </p:txBody>
+      </p:sp>
+      <p:sp>
+        <p:nvSpPr>
+          <p:cNvPr id="31" name="Rectangle 30"/>
           <p:cNvSpPr/>
           <p:nvPr/>
         </p:nvSpPr>
         <p:spPr>
           <a:xfrm>
-            <a:off x="2926080" y="2670048"/>
-            <a:ext cx="1280160" cy="530352"/>
+            <a:off x="1984248" y="2670048"/>
+            <a:ext cx="1828800" cy="530352"/>
           </a:xfrm>
           <a:prstGeom prst="rect">
             <a:avLst/>
@@ -6712,14 +6871,14 @@
       </p:sp>
       <p:sp>
         <p:nvSpPr>
-          <p:cNvPr id="28" name="TextBox 27"/>
-          <p:cNvSpPr txBox="1"/>
-          <p:nvPr/>
-        </p:nvSpPr>
-        <p:spPr>
-          <a:xfrm>
-            <a:off x="2980944" y="2807208"/>
-            <a:ext cx="1170431" cy="146304"/>
+          <p:cNvPr id="32" name="TextBox 31"/>
+          <p:cNvSpPr txBox="1"/>
+          <p:nvPr/>
+        </p:nvSpPr>
+        <p:spPr>
+          <a:xfrm>
+            <a:off x="2039112" y="2807208"/>
+            <a:ext cx="1719072" cy="146304"/>
           </a:xfrm>
           <a:prstGeom prst="rect">
             <a:avLst/>
@@ -6740,21 +6899,21 @@
                 </a:solidFill>
                 <a:latin typeface="Aptos"/>
               </a:rPr>
-              <a:t>$1,000</a:t>
-            </a:r>
-          </a:p>
-        </p:txBody>
-      </p:sp>
-      <p:sp>
-        <p:nvSpPr>
-          <p:cNvPr id="29" name="Rectangle 28"/>
+              <a:t>$1,000 credit</a:t>
+            </a:r>
+          </a:p>
+        </p:txBody>
+      </p:sp>
+      <p:sp>
+        <p:nvSpPr>
+          <p:cNvPr id="33" name="Rectangle 32"/>
           <p:cNvSpPr/>
           <p:nvPr/>
         </p:nvSpPr>
         <p:spPr>
           <a:xfrm>
-            <a:off x="4206240" y="2670048"/>
-            <a:ext cx="1097280" cy="530352"/>
+            <a:off x="3813048" y="2670048"/>
+            <a:ext cx="1234440" cy="530352"/>
           </a:xfrm>
           <a:prstGeom prst="rect">
             <a:avLst/>
@@ -6792,14 +6951,14 @@
       </p:sp>
       <p:sp>
         <p:nvSpPr>
-          <p:cNvPr id="30" name="TextBox 29"/>
-          <p:cNvSpPr txBox="1"/>
-          <p:nvPr/>
-        </p:nvSpPr>
-        <p:spPr>
-          <a:xfrm>
-            <a:off x="4261103" y="2807208"/>
-            <a:ext cx="987552" cy="146304"/>
+          <p:cNvPr id="34" name="TextBox 33"/>
+          <p:cNvSpPr txBox="1"/>
+          <p:nvPr/>
+        </p:nvSpPr>
+        <p:spPr>
+          <a:xfrm>
+            <a:off x="3867911" y="2807208"/>
+            <a:ext cx="1124712" cy="146304"/>
           </a:xfrm>
           <a:prstGeom prst="rect">
             <a:avLst/>
@@ -6820,21 +6979,21 @@
                 </a:solidFill>
                 <a:latin typeface="Aptos"/>
               </a:rPr>
-              <a:t>2 units</a:t>
-            </a:r>
-          </a:p>
-        </p:txBody>
-      </p:sp>
-      <p:sp>
-        <p:nvSpPr>
-          <p:cNvPr id="31" name="Rectangle 30"/>
+              <a:t>2 shares</a:t>
+            </a:r>
+          </a:p>
+        </p:txBody>
+      </p:sp>
+      <p:sp>
+        <p:nvSpPr>
+          <p:cNvPr id="35" name="Rectangle 34"/>
           <p:cNvSpPr/>
           <p:nvPr/>
         </p:nvSpPr>
         <p:spPr>
           <a:xfrm>
-            <a:off x="5303520" y="2670048"/>
-            <a:ext cx="5029200" cy="530352"/>
+            <a:off x="5047488" y="2670048"/>
+            <a:ext cx="1508760" cy="530352"/>
           </a:xfrm>
           <a:prstGeom prst="rect">
             <a:avLst/>
@@ -6872,14 +7031,14 @@
       </p:sp>
       <p:sp>
         <p:nvSpPr>
-          <p:cNvPr id="32" name="TextBox 31"/>
-          <p:cNvSpPr txBox="1"/>
-          <p:nvPr/>
-        </p:nvSpPr>
-        <p:spPr>
-          <a:xfrm>
-            <a:off x="5358383" y="2807208"/>
-            <a:ext cx="4919472" cy="146304"/>
+          <p:cNvPr id="36" name="TextBox 35"/>
+          <p:cNvSpPr txBox="1"/>
+          <p:nvPr/>
+        </p:nvSpPr>
+        <p:spPr>
+          <a:xfrm>
+            <a:off x="5102351" y="2807208"/>
+            <a:ext cx="1399031" cy="146304"/>
           </a:xfrm>
           <a:prstGeom prst="rect">
             <a:avLst/>
@@ -6899,21 +7058,100 @@
                 </a:solidFill>
                 <a:latin typeface="Aptos"/>
               </a:rPr>
-              <a:t>Split across 1-2 businesses</a:t>
-            </a:r>
-          </a:p>
-        </p:txBody>
-      </p:sp>
-      <p:sp>
-        <p:nvSpPr>
-          <p:cNvPr id="33" name="Rectangle 32"/>
+              <a:t>10% referral</a:t>
+            </a:r>
+          </a:p>
+        </p:txBody>
+      </p:sp>
+      <p:sp>
+        <p:nvSpPr>
+          <p:cNvPr id="37" name="Rectangle 36"/>
           <p:cNvSpPr/>
           <p:nvPr/>
         </p:nvSpPr>
         <p:spPr>
           <a:xfrm>
-            <a:off x="914400" y="3236976"/>
-            <a:ext cx="2011680" cy="530352"/>
+            <a:off x="6556248" y="2670048"/>
+            <a:ext cx="3794760" cy="530352"/>
+          </a:xfrm>
+          <a:prstGeom prst="rect">
+            <a:avLst/>
+          </a:prstGeom>
+          <a:solidFill>
+            <a:srgbClr val="093036"/>
+          </a:solidFill>
+          <a:ln>
+            <a:solidFill>
+              <a:srgbClr val="1F525A"/>
+            </a:solidFill>
+          </a:ln>
+        </p:spPr>
+        <p:style>
+          <a:lnRef idx="1">
+            <a:schemeClr val="accent1"/>
+          </a:lnRef>
+          <a:fillRef idx="3">
+            <a:schemeClr val="accent1"/>
+          </a:fillRef>
+          <a:effectRef idx="2">
+            <a:schemeClr val="accent1"/>
+          </a:effectRef>
+          <a:fontRef idx="minor">
+            <a:schemeClr val="lt1"/>
+          </a:fontRef>
+        </p:style>
+        <p:txBody>
+          <a:bodyPr rtlCol="0" anchor="ctr"/>
+          <a:lstStyle/>
+          <a:p>
+            <a:pPr algn="ctr"/>
+          </a:p>
+        </p:txBody>
+      </p:sp>
+      <p:sp>
+        <p:nvSpPr>
+          <p:cNvPr id="38" name="TextBox 37"/>
+          <p:cNvSpPr txBox="1"/>
+          <p:nvPr/>
+        </p:nvSpPr>
+        <p:spPr>
+          <a:xfrm>
+            <a:off x="6611112" y="2807208"/>
+            <a:ext cx="3685032" cy="146304"/>
+          </a:xfrm>
+          <a:prstGeom prst="rect">
+            <a:avLst/>
+          </a:prstGeom>
+          <a:noFill/>
+        </p:spPr>
+        <p:txBody>
+          <a:bodyPr wrap="square">
+            <a:spAutoFit/>
+          </a:bodyPr>
+          <a:lstStyle/>
+          <a:p>
+            <a:r>
+              <a:rPr sz="800" b="0">
+                <a:solidFill>
+                  <a:srgbClr val="B9CACF"/>
+                </a:solidFill>
+                <a:latin typeface="Aptos"/>
+              </a:rPr>
+              <a:t>2D1N company tour</a:t>
+            </a:r>
+          </a:p>
+        </p:txBody>
+      </p:sp>
+      <p:sp>
+        <p:nvSpPr>
+          <p:cNvPr id="39" name="Rectangle 38"/>
+          <p:cNvSpPr/>
+          <p:nvPr/>
+        </p:nvSpPr>
+        <p:spPr>
+          <a:xfrm>
+            <a:off x="749808" y="3236976"/>
+            <a:ext cx="1234440" cy="530352"/>
           </a:xfrm>
           <a:prstGeom prst="rect">
             <a:avLst/>
@@ -6951,14 +7189,14 @@
       </p:sp>
       <p:sp>
         <p:nvSpPr>
-          <p:cNvPr id="34" name="TextBox 33"/>
-          <p:cNvSpPr txBox="1"/>
-          <p:nvPr/>
-        </p:nvSpPr>
-        <p:spPr>
-          <a:xfrm>
-            <a:off x="969264" y="3374136"/>
-            <a:ext cx="1901952" cy="146304"/>
+          <p:cNvPr id="40" name="TextBox 39"/>
+          <p:cNvSpPr txBox="1"/>
+          <p:nvPr/>
+        </p:nvSpPr>
+        <p:spPr>
+          <a:xfrm>
+            <a:off x="804671" y="3374136"/>
+            <a:ext cx="1124712" cy="146304"/>
           </a:xfrm>
           <a:prstGeom prst="rect">
             <a:avLst/>
@@ -6979,21 +7217,21 @@
                 </a:solidFill>
                 <a:latin typeface="Aptos"/>
               </a:rPr>
-              <a:t>Growth Pack</a:t>
-            </a:r>
-          </a:p>
-        </p:txBody>
-      </p:sp>
-      <p:sp>
-        <p:nvSpPr>
-          <p:cNvPr id="35" name="Rectangle 34"/>
+              <a:t>$3,000</a:t>
+            </a:r>
+          </a:p>
+        </p:txBody>
+      </p:sp>
+      <p:sp>
+        <p:nvSpPr>
+          <p:cNvPr id="41" name="Rectangle 40"/>
           <p:cNvSpPr/>
           <p:nvPr/>
         </p:nvSpPr>
         <p:spPr>
           <a:xfrm>
-            <a:off x="2926080" y="3236976"/>
-            <a:ext cx="1280160" cy="530352"/>
+            <a:off x="1984248" y="3236976"/>
+            <a:ext cx="1828800" cy="530352"/>
           </a:xfrm>
           <a:prstGeom prst="rect">
             <a:avLst/>
@@ -7031,14 +7269,14 @@
       </p:sp>
       <p:sp>
         <p:nvSpPr>
-          <p:cNvPr id="36" name="TextBox 35"/>
-          <p:cNvSpPr txBox="1"/>
-          <p:nvPr/>
-        </p:nvSpPr>
-        <p:spPr>
-          <a:xfrm>
-            <a:off x="2980944" y="3374136"/>
-            <a:ext cx="1170431" cy="146304"/>
+          <p:cNvPr id="42" name="TextBox 41"/>
+          <p:cNvSpPr txBox="1"/>
+          <p:nvPr/>
+        </p:nvSpPr>
+        <p:spPr>
+          <a:xfrm>
+            <a:off x="2039112" y="3374136"/>
+            <a:ext cx="1719072" cy="146304"/>
           </a:xfrm>
           <a:prstGeom prst="rect">
             <a:avLst/>
@@ -7059,21 +7297,21 @@
                 </a:solidFill>
                 <a:latin typeface="Aptos"/>
               </a:rPr>
-              <a:t>$3,000</a:t>
-            </a:r>
-          </a:p>
-        </p:txBody>
-      </p:sp>
-      <p:sp>
-        <p:nvSpPr>
-          <p:cNvPr id="37" name="Rectangle 36"/>
+              <a:t>$3,000 credit</a:t>
+            </a:r>
+          </a:p>
+        </p:txBody>
+      </p:sp>
+      <p:sp>
+        <p:nvSpPr>
+          <p:cNvPr id="43" name="Rectangle 42"/>
           <p:cNvSpPr/>
           <p:nvPr/>
         </p:nvSpPr>
         <p:spPr>
           <a:xfrm>
-            <a:off x="4206240" y="3236976"/>
-            <a:ext cx="1097280" cy="530352"/>
+            <a:off x="3813048" y="3236976"/>
+            <a:ext cx="1234440" cy="530352"/>
           </a:xfrm>
           <a:prstGeom prst="rect">
             <a:avLst/>
@@ -7111,14 +7349,14 @@
       </p:sp>
       <p:sp>
         <p:nvSpPr>
-          <p:cNvPr id="38" name="TextBox 37"/>
-          <p:cNvSpPr txBox="1"/>
-          <p:nvPr/>
-        </p:nvSpPr>
-        <p:spPr>
-          <a:xfrm>
-            <a:off x="4261103" y="3374136"/>
-            <a:ext cx="987552" cy="146304"/>
+          <p:cNvPr id="44" name="TextBox 43"/>
+          <p:cNvSpPr txBox="1"/>
+          <p:nvPr/>
+        </p:nvSpPr>
+        <p:spPr>
+          <a:xfrm>
+            <a:off x="3867911" y="3374136"/>
+            <a:ext cx="1124712" cy="146304"/>
           </a:xfrm>
           <a:prstGeom prst="rect">
             <a:avLst/>
@@ -7139,21 +7377,21 @@
                 </a:solidFill>
                 <a:latin typeface="Aptos"/>
               </a:rPr>
-              <a:t>6 units</a:t>
-            </a:r>
-          </a:p>
-        </p:txBody>
-      </p:sp>
-      <p:sp>
-        <p:nvSpPr>
-          <p:cNvPr id="39" name="Rectangle 38"/>
+              <a:t>6 shares</a:t>
+            </a:r>
+          </a:p>
+        </p:txBody>
+      </p:sp>
+      <p:sp>
+        <p:nvSpPr>
+          <p:cNvPr id="45" name="Rectangle 44"/>
           <p:cNvSpPr/>
           <p:nvPr/>
         </p:nvSpPr>
         <p:spPr>
           <a:xfrm>
-            <a:off x="5303520" y="3236976"/>
-            <a:ext cx="5029200" cy="530352"/>
+            <a:off x="5047488" y="3236976"/>
+            <a:ext cx="1508760" cy="530352"/>
           </a:xfrm>
           <a:prstGeom prst="rect">
             <a:avLst/>
@@ -7191,14 +7429,14 @@
       </p:sp>
       <p:sp>
         <p:nvSpPr>
-          <p:cNvPr id="40" name="TextBox 39"/>
-          <p:cNvSpPr txBox="1"/>
-          <p:nvPr/>
-        </p:nvSpPr>
-        <p:spPr>
-          <a:xfrm>
-            <a:off x="5358383" y="3374136"/>
-            <a:ext cx="4919472" cy="146304"/>
+          <p:cNvPr id="46" name="TextBox 45"/>
+          <p:cNvSpPr txBox="1"/>
+          <p:nvPr/>
+        </p:nvSpPr>
+        <p:spPr>
+          <a:xfrm>
+            <a:off x="5102351" y="3374136"/>
+            <a:ext cx="1399031" cy="146304"/>
           </a:xfrm>
           <a:prstGeom prst="rect">
             <a:avLst/>
@@ -7218,21 +7456,100 @@
                 </a:solidFill>
                 <a:latin typeface="Aptos"/>
               </a:rPr>
-              <a:t>Flexible project exposure</a:t>
-            </a:r>
-          </a:p>
-        </p:txBody>
-      </p:sp>
-      <p:sp>
-        <p:nvSpPr>
-          <p:cNvPr id="41" name="Rectangle 40"/>
+              <a:t>10% referral</a:t>
+            </a:r>
+          </a:p>
+        </p:txBody>
+      </p:sp>
+      <p:sp>
+        <p:nvSpPr>
+          <p:cNvPr id="47" name="Rectangle 46"/>
           <p:cNvSpPr/>
           <p:nvPr/>
         </p:nvSpPr>
         <p:spPr>
           <a:xfrm>
-            <a:off x="914400" y="3803904"/>
-            <a:ext cx="2011680" cy="530352"/>
+            <a:off x="6556248" y="3236976"/>
+            <a:ext cx="3794760" cy="530352"/>
+          </a:xfrm>
+          <a:prstGeom prst="rect">
+            <a:avLst/>
+          </a:prstGeom>
+          <a:solidFill>
+            <a:srgbClr val="07272D"/>
+          </a:solidFill>
+          <a:ln>
+            <a:solidFill>
+              <a:srgbClr val="1F525A"/>
+            </a:solidFill>
+          </a:ln>
+        </p:spPr>
+        <p:style>
+          <a:lnRef idx="1">
+            <a:schemeClr val="accent1"/>
+          </a:lnRef>
+          <a:fillRef idx="3">
+            <a:schemeClr val="accent1"/>
+          </a:fillRef>
+          <a:effectRef idx="2">
+            <a:schemeClr val="accent1"/>
+          </a:effectRef>
+          <a:fontRef idx="minor">
+            <a:schemeClr val="lt1"/>
+          </a:fontRef>
+        </p:style>
+        <p:txBody>
+          <a:bodyPr rtlCol="0" anchor="ctr"/>
+          <a:lstStyle/>
+          <a:p>
+            <a:pPr algn="ctr"/>
+          </a:p>
+        </p:txBody>
+      </p:sp>
+      <p:sp>
+        <p:nvSpPr>
+          <p:cNvPr id="48" name="TextBox 47"/>
+          <p:cNvSpPr txBox="1"/>
+          <p:nvPr/>
+        </p:nvSpPr>
+        <p:spPr>
+          <a:xfrm>
+            <a:off x="6611112" y="3374136"/>
+            <a:ext cx="3685032" cy="146304"/>
+          </a:xfrm>
+          <a:prstGeom prst="rect">
+            <a:avLst/>
+          </a:prstGeom>
+          <a:noFill/>
+        </p:spPr>
+        <p:txBody>
+          <a:bodyPr wrap="square">
+            <a:spAutoFit/>
+          </a:bodyPr>
+          <a:lstStyle/>
+          <a:p>
+            <a:r>
+              <a:rPr sz="800" b="0">
+                <a:solidFill>
+                  <a:srgbClr val="B9CACF"/>
+                </a:solidFill>
+                <a:latin typeface="Aptos"/>
+              </a:rPr>
+              <a:t>3D2N visit + entertainment</a:t>
+            </a:r>
+          </a:p>
+        </p:txBody>
+      </p:sp>
+      <p:sp>
+        <p:nvSpPr>
+          <p:cNvPr id="49" name="Rectangle 48"/>
+          <p:cNvSpPr/>
+          <p:nvPr/>
+        </p:nvSpPr>
+        <p:spPr>
+          <a:xfrm>
+            <a:off x="749808" y="3803904"/>
+            <a:ext cx="1234440" cy="530352"/>
           </a:xfrm>
           <a:prstGeom prst="rect">
             <a:avLst/>
@@ -7270,14 +7587,14 @@
       </p:sp>
       <p:sp>
         <p:nvSpPr>
-          <p:cNvPr id="42" name="TextBox 41"/>
-          <p:cNvSpPr txBox="1"/>
-          <p:nvPr/>
-        </p:nvSpPr>
-        <p:spPr>
-          <a:xfrm>
-            <a:off x="969264" y="3941064"/>
-            <a:ext cx="1901952" cy="146304"/>
+          <p:cNvPr id="50" name="TextBox 49"/>
+          <p:cNvSpPr txBox="1"/>
+          <p:nvPr/>
+        </p:nvSpPr>
+        <p:spPr>
+          <a:xfrm>
+            <a:off x="804671" y="3941064"/>
+            <a:ext cx="1124712" cy="146304"/>
           </a:xfrm>
           <a:prstGeom prst="rect">
             <a:avLst/>
@@ -7298,21 +7615,21 @@
                 </a:solidFill>
                 <a:latin typeface="Aptos"/>
               </a:rPr>
-              <a:t>Founder Pack</a:t>
-            </a:r>
-          </a:p>
-        </p:txBody>
-      </p:sp>
-      <p:sp>
-        <p:nvSpPr>
-          <p:cNvPr id="43" name="Rectangle 42"/>
+              <a:t>$5,000</a:t>
+            </a:r>
+          </a:p>
+        </p:txBody>
+      </p:sp>
+      <p:sp>
+        <p:nvSpPr>
+          <p:cNvPr id="51" name="Rectangle 50"/>
           <p:cNvSpPr/>
           <p:nvPr/>
         </p:nvSpPr>
         <p:spPr>
           <a:xfrm>
-            <a:off x="2926080" y="3803904"/>
-            <a:ext cx="1280160" cy="530352"/>
+            <a:off x="1984248" y="3803904"/>
+            <a:ext cx="1828800" cy="530352"/>
           </a:xfrm>
           <a:prstGeom prst="rect">
             <a:avLst/>
@@ -7350,14 +7667,14 @@
       </p:sp>
       <p:sp>
         <p:nvSpPr>
-          <p:cNvPr id="44" name="TextBox 43"/>
-          <p:cNvSpPr txBox="1"/>
-          <p:nvPr/>
-        </p:nvSpPr>
-        <p:spPr>
-          <a:xfrm>
-            <a:off x="2980944" y="3941064"/>
-            <a:ext cx="1170431" cy="146304"/>
+          <p:cNvPr id="52" name="TextBox 51"/>
+          <p:cNvSpPr txBox="1"/>
+          <p:nvPr/>
+        </p:nvSpPr>
+        <p:spPr>
+          <a:xfrm>
+            <a:off x="2039112" y="3941064"/>
+            <a:ext cx="1719072" cy="146304"/>
           </a:xfrm>
           <a:prstGeom prst="rect">
             <a:avLst/>
@@ -7378,21 +7695,21 @@
                 </a:solidFill>
                 <a:latin typeface="Aptos"/>
               </a:rPr>
-              <a:t>$5,000</a:t>
-            </a:r>
-          </a:p>
-        </p:txBody>
-      </p:sp>
-      <p:sp>
-        <p:nvSpPr>
-          <p:cNvPr id="45" name="Rectangle 44"/>
+              <a:t>$7,000 credit</a:t>
+            </a:r>
+          </a:p>
+        </p:txBody>
+      </p:sp>
+      <p:sp>
+        <p:nvSpPr>
+          <p:cNvPr id="53" name="Rectangle 52"/>
           <p:cNvSpPr/>
           <p:nvPr/>
         </p:nvSpPr>
         <p:spPr>
           <a:xfrm>
-            <a:off x="4206240" y="3803904"/>
-            <a:ext cx="1097280" cy="530352"/>
+            <a:off x="3813048" y="3803904"/>
+            <a:ext cx="1234440" cy="530352"/>
           </a:xfrm>
           <a:prstGeom prst="rect">
             <a:avLst/>
@@ -7430,14 +7747,14 @@
       </p:sp>
       <p:sp>
         <p:nvSpPr>
-          <p:cNvPr id="46" name="TextBox 45"/>
-          <p:cNvSpPr txBox="1"/>
-          <p:nvPr/>
-        </p:nvSpPr>
-        <p:spPr>
-          <a:xfrm>
-            <a:off x="4261103" y="3941064"/>
-            <a:ext cx="987552" cy="146304"/>
+          <p:cNvPr id="54" name="TextBox 53"/>
+          <p:cNvSpPr txBox="1"/>
+          <p:nvPr/>
+        </p:nvSpPr>
+        <p:spPr>
+          <a:xfrm>
+            <a:off x="3867911" y="3941064"/>
+            <a:ext cx="1124712" cy="146304"/>
           </a:xfrm>
           <a:prstGeom prst="rect">
             <a:avLst/>
@@ -7458,21 +7775,21 @@
                 </a:solidFill>
                 <a:latin typeface="Aptos"/>
               </a:rPr>
-              <a:t>10 units</a:t>
-            </a:r>
-          </a:p>
-        </p:txBody>
-      </p:sp>
-      <p:sp>
-        <p:nvSpPr>
-          <p:cNvPr id="47" name="Rectangle 46"/>
+              <a:t>10 shares</a:t>
+            </a:r>
+          </a:p>
+        </p:txBody>
+      </p:sp>
+      <p:sp>
+        <p:nvSpPr>
+          <p:cNvPr id="55" name="Rectangle 54"/>
           <p:cNvSpPr/>
           <p:nvPr/>
         </p:nvSpPr>
         <p:spPr>
           <a:xfrm>
-            <a:off x="5303520" y="3803904"/>
-            <a:ext cx="5029200" cy="530352"/>
+            <a:off x="5047488" y="3803904"/>
+            <a:ext cx="1508760" cy="530352"/>
           </a:xfrm>
           <a:prstGeom prst="rect">
             <a:avLst/>
@@ -7510,14 +7827,14 @@
       </p:sp>
       <p:sp>
         <p:nvSpPr>
-          <p:cNvPr id="48" name="TextBox 47"/>
-          <p:cNvSpPr txBox="1"/>
-          <p:nvPr/>
-        </p:nvSpPr>
-        <p:spPr>
-          <a:xfrm>
-            <a:off x="5358383" y="3941064"/>
-            <a:ext cx="4919472" cy="146304"/>
+          <p:cNvPr id="56" name="TextBox 55"/>
+          <p:cNvSpPr txBox="1"/>
+          <p:nvPr/>
+        </p:nvSpPr>
+        <p:spPr>
+          <a:xfrm>
+            <a:off x="5102351" y="3941064"/>
+            <a:ext cx="1399031" cy="146304"/>
           </a:xfrm>
           <a:prstGeom prst="rect">
             <a:avLst/>
@@ -7537,21 +7854,100 @@
                 </a:solidFill>
                 <a:latin typeface="Aptos"/>
               </a:rPr>
-              <a:t>Serious early supporter</a:t>
-            </a:r>
-          </a:p>
-        </p:txBody>
-      </p:sp>
-      <p:sp>
-        <p:nvSpPr>
-          <p:cNvPr id="49" name="Rectangle 48"/>
+              <a:t>10% referral</a:t>
+            </a:r>
+          </a:p>
+        </p:txBody>
+      </p:sp>
+      <p:sp>
+        <p:nvSpPr>
+          <p:cNvPr id="57" name="Rectangle 56"/>
           <p:cNvSpPr/>
           <p:nvPr/>
         </p:nvSpPr>
         <p:spPr>
           <a:xfrm>
-            <a:off x="914400" y="4370831"/>
-            <a:ext cx="2011680" cy="530352"/>
+            <a:off x="6556248" y="3803904"/>
+            <a:ext cx="3794760" cy="530352"/>
+          </a:xfrm>
+          <a:prstGeom prst="rect">
+            <a:avLst/>
+          </a:prstGeom>
+          <a:solidFill>
+            <a:srgbClr val="093036"/>
+          </a:solidFill>
+          <a:ln>
+            <a:solidFill>
+              <a:srgbClr val="1F525A"/>
+            </a:solidFill>
+          </a:ln>
+        </p:spPr>
+        <p:style>
+          <a:lnRef idx="1">
+            <a:schemeClr val="accent1"/>
+          </a:lnRef>
+          <a:fillRef idx="3">
+            <a:schemeClr val="accent1"/>
+          </a:fillRef>
+          <a:effectRef idx="2">
+            <a:schemeClr val="accent1"/>
+          </a:effectRef>
+          <a:fontRef idx="minor">
+            <a:schemeClr val="lt1"/>
+          </a:fontRef>
+        </p:style>
+        <p:txBody>
+          <a:bodyPr rtlCol="0" anchor="ctr"/>
+          <a:lstStyle/>
+          <a:p>
+            <a:pPr algn="ctr"/>
+          </a:p>
+        </p:txBody>
+      </p:sp>
+      <p:sp>
+        <p:nvSpPr>
+          <p:cNvPr id="58" name="TextBox 57"/>
+          <p:cNvSpPr txBox="1"/>
+          <p:nvPr/>
+        </p:nvSpPr>
+        <p:spPr>
+          <a:xfrm>
+            <a:off x="6611112" y="3941064"/>
+            <a:ext cx="3685032" cy="146304"/>
+          </a:xfrm>
+          <a:prstGeom prst="rect">
+            <a:avLst/>
+          </a:prstGeom>
+          <a:noFill/>
+        </p:spPr>
+        <p:txBody>
+          <a:bodyPr wrap="square">
+            <a:spAutoFit/>
+          </a:bodyPr>
+          <a:lstStyle/>
+          <a:p>
+            <a:r>
+              <a:rPr sz="800" b="0">
+                <a:solidFill>
+                  <a:srgbClr val="B9CACF"/>
+                </a:solidFill>
+                <a:latin typeface="Aptos"/>
+              </a:rPr>
+              <a:t>3D2N visit + entertainment</a:t>
+            </a:r>
+          </a:p>
+        </p:txBody>
+      </p:sp>
+      <p:sp>
+        <p:nvSpPr>
+          <p:cNvPr id="59" name="Rectangle 58"/>
+          <p:cNvSpPr/>
+          <p:nvPr/>
+        </p:nvSpPr>
+        <p:spPr>
+          <a:xfrm>
+            <a:off x="749808" y="4370831"/>
+            <a:ext cx="1234440" cy="530352"/>
           </a:xfrm>
           <a:prstGeom prst="rect">
             <a:avLst/>
@@ -7589,14 +7985,14 @@
       </p:sp>
       <p:sp>
         <p:nvSpPr>
-          <p:cNvPr id="50" name="TextBox 49"/>
-          <p:cNvSpPr txBox="1"/>
-          <p:nvPr/>
-        </p:nvSpPr>
-        <p:spPr>
-          <a:xfrm>
-            <a:off x="969264" y="4507992"/>
-            <a:ext cx="1901952" cy="146304"/>
+          <p:cNvPr id="60" name="TextBox 59"/>
+          <p:cNvSpPr txBox="1"/>
+          <p:nvPr/>
+        </p:nvSpPr>
+        <p:spPr>
+          <a:xfrm>
+            <a:off x="804671" y="4507992"/>
+            <a:ext cx="1124712" cy="146304"/>
           </a:xfrm>
           <a:prstGeom prst="rect">
             <a:avLst/>
@@ -7617,21 +8013,21 @@
                 </a:solidFill>
                 <a:latin typeface="Aptos"/>
               </a:rPr>
-              <a:t>Anchor Pack</a:t>
-            </a:r>
-          </a:p>
-        </p:txBody>
-      </p:sp>
-      <p:sp>
-        <p:nvSpPr>
-          <p:cNvPr id="51" name="Rectangle 50"/>
+              <a:t>$10,000</a:t>
+            </a:r>
+          </a:p>
+        </p:txBody>
+      </p:sp>
+      <p:sp>
+        <p:nvSpPr>
+          <p:cNvPr id="61" name="Rectangle 60"/>
           <p:cNvSpPr/>
           <p:nvPr/>
         </p:nvSpPr>
         <p:spPr>
           <a:xfrm>
-            <a:off x="2926080" y="4370831"/>
-            <a:ext cx="1280160" cy="530352"/>
+            <a:off x="1984248" y="4370831"/>
+            <a:ext cx="1828800" cy="530352"/>
           </a:xfrm>
           <a:prstGeom prst="rect">
             <a:avLst/>
@@ -7669,14 +8065,14 @@
       </p:sp>
       <p:sp>
         <p:nvSpPr>
-          <p:cNvPr id="52" name="TextBox 51"/>
-          <p:cNvSpPr txBox="1"/>
-          <p:nvPr/>
-        </p:nvSpPr>
-        <p:spPr>
-          <a:xfrm>
-            <a:off x="2980944" y="4507992"/>
-            <a:ext cx="1170431" cy="146304"/>
+          <p:cNvPr id="62" name="TextBox 61"/>
+          <p:cNvSpPr txBox="1"/>
+          <p:nvPr/>
+        </p:nvSpPr>
+        <p:spPr>
+          <a:xfrm>
+            <a:off x="2039112" y="4507992"/>
+            <a:ext cx="1719072" cy="146304"/>
           </a:xfrm>
           <a:prstGeom prst="rect">
             <a:avLst/>
@@ -7697,21 +8093,21 @@
                 </a:solidFill>
                 <a:latin typeface="Aptos"/>
               </a:rPr>
-              <a:t>$10,000</a:t>
-            </a:r>
-          </a:p>
-        </p:txBody>
-      </p:sp>
-      <p:sp>
-        <p:nvSpPr>
-          <p:cNvPr id="53" name="Rectangle 52"/>
+              <a:t>$15,000 credit</a:t>
+            </a:r>
+          </a:p>
+        </p:txBody>
+      </p:sp>
+      <p:sp>
+        <p:nvSpPr>
+          <p:cNvPr id="63" name="Rectangle 62"/>
           <p:cNvSpPr/>
           <p:nvPr/>
         </p:nvSpPr>
         <p:spPr>
           <a:xfrm>
-            <a:off x="4206240" y="4370831"/>
-            <a:ext cx="1097280" cy="530352"/>
+            <a:off x="3813048" y="4370831"/>
+            <a:ext cx="1234440" cy="530352"/>
           </a:xfrm>
           <a:prstGeom prst="rect">
             <a:avLst/>
@@ -7749,14 +8145,14 @@
       </p:sp>
       <p:sp>
         <p:nvSpPr>
-          <p:cNvPr id="54" name="TextBox 53"/>
-          <p:cNvSpPr txBox="1"/>
-          <p:nvPr/>
-        </p:nvSpPr>
-        <p:spPr>
-          <a:xfrm>
-            <a:off x="4261103" y="4507992"/>
-            <a:ext cx="987552" cy="146304"/>
+          <p:cNvPr id="64" name="TextBox 63"/>
+          <p:cNvSpPr txBox="1"/>
+          <p:nvPr/>
+        </p:nvSpPr>
+        <p:spPr>
+          <a:xfrm>
+            <a:off x="3867911" y="4507992"/>
+            <a:ext cx="1124712" cy="146304"/>
           </a:xfrm>
           <a:prstGeom prst="rect">
             <a:avLst/>
@@ -7777,21 +8173,21 @@
                 </a:solidFill>
                 <a:latin typeface="Aptos"/>
               </a:rPr>
-              <a:t>20 units</a:t>
-            </a:r>
-          </a:p>
-        </p:txBody>
-      </p:sp>
-      <p:sp>
-        <p:nvSpPr>
-          <p:cNvPr id="55" name="Rectangle 54"/>
+              <a:t>20 shares</a:t>
+            </a:r>
+          </a:p>
+        </p:txBody>
+      </p:sp>
+      <p:sp>
+        <p:nvSpPr>
+          <p:cNvPr id="65" name="Rectangle 64"/>
           <p:cNvSpPr/>
           <p:nvPr/>
         </p:nvSpPr>
         <p:spPr>
           <a:xfrm>
-            <a:off x="5303520" y="4370831"/>
-            <a:ext cx="5029200" cy="530352"/>
+            <a:off x="5047488" y="4370831"/>
+            <a:ext cx="1508760" cy="530352"/>
           </a:xfrm>
           <a:prstGeom prst="rect">
             <a:avLst/>
@@ -7829,14 +8225,14 @@
       </p:sp>
       <p:sp>
         <p:nvSpPr>
-          <p:cNvPr id="56" name="TextBox 55"/>
-          <p:cNvSpPr txBox="1"/>
-          <p:nvPr/>
-        </p:nvSpPr>
-        <p:spPr>
-          <a:xfrm>
-            <a:off x="5358383" y="4507992"/>
-            <a:ext cx="4919472" cy="146304"/>
+          <p:cNvPr id="66" name="TextBox 65"/>
+          <p:cNvSpPr txBox="1"/>
+          <p:nvPr/>
+        </p:nvSpPr>
+        <p:spPr>
+          <a:xfrm>
+            <a:off x="5102351" y="4507992"/>
+            <a:ext cx="1399031" cy="146304"/>
           </a:xfrm>
           <a:prstGeom prst="rect">
             <a:avLst/>
@@ -7856,21 +8252,100 @@
                 </a:solidFill>
                 <a:latin typeface="Aptos"/>
               </a:rPr>
-              <a:t>Major participation</a:t>
-            </a:r>
-          </a:p>
-        </p:txBody>
-      </p:sp>
-      <p:sp>
-        <p:nvSpPr>
-          <p:cNvPr id="57" name="Rounded Rectangle 56"/>
+              <a:t>10% referral</a:t>
+            </a:r>
+          </a:p>
+        </p:txBody>
+      </p:sp>
+      <p:sp>
+        <p:nvSpPr>
+          <p:cNvPr id="67" name="Rectangle 66"/>
           <p:cNvSpPr/>
           <p:nvPr/>
         </p:nvSpPr>
         <p:spPr>
           <a:xfrm>
-            <a:off x="914400" y="5074920"/>
-            <a:ext cx="9418320" cy="658368"/>
+            <a:off x="6556248" y="4370831"/>
+            <a:ext cx="3794760" cy="530352"/>
+          </a:xfrm>
+          <a:prstGeom prst="rect">
+            <a:avLst/>
+          </a:prstGeom>
+          <a:solidFill>
+            <a:srgbClr val="07272D"/>
+          </a:solidFill>
+          <a:ln>
+            <a:solidFill>
+              <a:srgbClr val="1F525A"/>
+            </a:solidFill>
+          </a:ln>
+        </p:spPr>
+        <p:style>
+          <a:lnRef idx="1">
+            <a:schemeClr val="accent1"/>
+          </a:lnRef>
+          <a:fillRef idx="3">
+            <a:schemeClr val="accent1"/>
+          </a:fillRef>
+          <a:effectRef idx="2">
+            <a:schemeClr val="accent1"/>
+          </a:effectRef>
+          <a:fontRef idx="minor">
+            <a:schemeClr val="lt1"/>
+          </a:fontRef>
+        </p:style>
+        <p:txBody>
+          <a:bodyPr rtlCol="0" anchor="ctr"/>
+          <a:lstStyle/>
+          <a:p>
+            <a:pPr algn="ctr"/>
+          </a:p>
+        </p:txBody>
+      </p:sp>
+      <p:sp>
+        <p:nvSpPr>
+          <p:cNvPr id="68" name="TextBox 67"/>
+          <p:cNvSpPr txBox="1"/>
+          <p:nvPr/>
+        </p:nvSpPr>
+        <p:spPr>
+          <a:xfrm>
+            <a:off x="6611112" y="4507992"/>
+            <a:ext cx="3685032" cy="146304"/>
+          </a:xfrm>
+          <a:prstGeom prst="rect">
+            <a:avLst/>
+          </a:prstGeom>
+          <a:noFill/>
+        </p:spPr>
+        <p:txBody>
+          <a:bodyPr wrap="square">
+            <a:spAutoFit/>
+          </a:bodyPr>
+          <a:lstStyle/>
+          <a:p>
+            <a:r>
+              <a:rPr sz="800" b="0">
+                <a:solidFill>
+                  <a:srgbClr val="B9CACF"/>
+                </a:solidFill>
+                <a:latin typeface="Aptos"/>
+              </a:rPr>
+              <a:t>3D2N visit + entertainment</a:t>
+            </a:r>
+          </a:p>
+        </p:txBody>
+      </p:sp>
+      <p:sp>
+        <p:nvSpPr>
+          <p:cNvPr id="69" name="Rounded Rectangle 68"/>
+          <p:cNvSpPr/>
+          <p:nvPr/>
+        </p:nvSpPr>
+        <p:spPr>
+          <a:xfrm>
+            <a:off x="749808" y="5074920"/>
+            <a:ext cx="9738360" cy="658368"/>
           </a:xfrm>
           <a:prstGeom prst="roundRect">
             <a:avLst/>
@@ -7908,14 +8383,14 @@
       </p:sp>
       <p:sp>
         <p:nvSpPr>
-          <p:cNvPr id="58" name="TextBox 57"/>
-          <p:cNvSpPr txBox="1"/>
-          <p:nvPr/>
-        </p:nvSpPr>
-        <p:spPr>
-          <a:xfrm>
-            <a:off x="1078992" y="5202936"/>
-            <a:ext cx="9089136" cy="292608"/>
+          <p:cNvPr id="70" name="TextBox 69"/>
+          <p:cNvSpPr txBox="1"/>
+          <p:nvPr/>
+        </p:nvSpPr>
+        <p:spPr>
+          <a:xfrm>
+            <a:off x="914400" y="5202936"/>
+            <a:ext cx="9409176" cy="292608"/>
           </a:xfrm>
           <a:prstGeom prst="rect">
             <a:avLst/>
@@ -7935,48 +8410,48 @@
                 </a:solidFill>
                 <a:latin typeface="Aptos"/>
               </a:rPr>
-              <a:t>Example</a:t>
-            </a:r>
-          </a:p>
-        </p:txBody>
-      </p:sp>
-      <p:sp>
-        <p:nvSpPr>
-          <p:cNvPr id="59" name="TextBox 58"/>
-          <p:cNvSpPr txBox="1"/>
-          <p:nvPr/>
-        </p:nvSpPr>
-        <p:spPr>
-          <a:xfrm>
-            <a:off x="1078992" y="5568696"/>
-            <a:ext cx="9089136" cy="91439"/>
-          </a:xfrm>
-          <a:prstGeom prst="rect">
-            <a:avLst/>
-          </a:prstGeom>
-          <a:noFill/>
-        </p:spPr>
-        <p:txBody>
-          <a:bodyPr wrap="square">
-            <a:spAutoFit/>
-          </a:bodyPr>
-          <a:lstStyle/>
-          <a:p>
-            <a:r>
-              <a:rPr sz="900" b="0">
+              <a:t>Shared pool upside</a:t>
+            </a:r>
+          </a:p>
+        </p:txBody>
+      </p:sp>
+      <p:sp>
+        <p:nvSpPr>
+          <p:cNvPr id="71" name="TextBox 70"/>
+          <p:cNvSpPr txBox="1"/>
+          <p:nvPr/>
+        </p:nvSpPr>
+        <p:spPr>
+          <a:xfrm>
+            <a:off x="914400" y="5568696"/>
+            <a:ext cx="9409176" cy="91439"/>
+          </a:xfrm>
+          <a:prstGeom prst="rect">
+            <a:avLst/>
+          </a:prstGeom>
+          <a:noFill/>
+        </p:spPr>
+        <p:txBody>
+          <a:bodyPr wrap="square">
+            <a:spAutoFit/>
+          </a:bodyPr>
+          <a:lstStyle/>
+          <a:p>
+            <a:r>
+              <a:rPr sz="800" b="0">
                 <a:solidFill>
                   <a:srgbClr val="B9CACF"/>
                 </a:solidFill>
                 <a:latin typeface="Aptos"/>
               </a:rPr>
-              <a:t>$3,000 Growth Pack = 6 units. You can place all 6 into Pet Cafe, or split 2 KTV + 2 Live House + 2 Game House.</a:t>
-            </a:r>
-          </a:p>
-        </p:txBody>
-      </p:sp>
-      <p:sp>
-        <p:nvSpPr>
-          <p:cNvPr id="60" name="TextBox 59"/>
+              <a:t>Each share is based on $500 participation for two years. 40% of the company shared pool is allocated to participating investors, with projected 5-10x upside potential, not guaranteed.</a:t>
+            </a:r>
+          </a:p>
+        </p:txBody>
+      </p:sp>
+      <p:sp>
+        <p:nvSpPr>
+          <p:cNvPr id="72" name="TextBox 71"/>
           <p:cNvSpPr txBox="1"/>
           <p:nvPr/>
         </p:nvSpPr>
@@ -8010,7 +8485,7 @@
       </p:sp>
       <p:sp>
         <p:nvSpPr>
-          <p:cNvPr id="61" name="TextBox 60"/>
+          <p:cNvPr id="73" name="TextBox 72"/>
           <p:cNvSpPr txBox="1"/>
           <p:nvPr/>
         </p:nvSpPr>

</xml_diff>